<commit_message>
Add User Music Creation: 8086 RAM Composer (composer.asm) & 16-Step Studio Sequencer
</commit_message>
<xml_diff>
--- a/Assets/Documentation/CrimsonOrbit_Presentation.pptx
+++ b/Assets/Documentation/CrimsonOrbit_Presentation.pptx
@@ -18,6 +18,7 @@
     <p:sldId id="266" r:id="rId17"/>
     <p:sldId id="267" r:id="rId18"/>
     <p:sldId id="268" r:id="rId19"/>
+    <p:sldId id="269" r:id="rId20"/>
   </p:sldIdLst>
   <p:sldSz cx="12191695" cy="6858000" type="screen4x3"/>
   <p:notesSz cx="6858000" cy="9144000"/>
@@ -4857,7 +4858,7 @@
               </a:defRPr>
             </a:pPr>
             <a:r>
-              <a:t>How to Run Our Project &amp; Live Demo</a:t>
+              <a:t>User Music Creation — Custom Song Composer &amp; Sequencer</a:t>
             </a:r>
           </a:p>
         </p:txBody>
@@ -4980,7 +4981,7 @@
               </a:defRPr>
             </a:pPr>
             <a:r>
-              <a:t>1. Running in emu8086 (Assembly)</a:t>
+              <a:t>In emu8086 Assembly (composer.asm)</a:t>
             </a:r>
           </a:p>
         </p:txBody>
@@ -5015,7 +5016,7 @@
               </a:defRPr>
             </a:pPr>
             <a:r>
-              <a:t>Assembly Emulation Demo</a:t>
+              <a:t>Live 8086 RAM Track Recorder</a:t>
             </a:r>
           </a:p>
         </p:txBody>
@@ -5053,67 +5054,112 @@
               </a:defRPr>
             </a:pPr>
             <a:r>
-              <a:t>•  Step 1: Open emu8086 software on the computer.</a:t>
-            </a:r>
-          </a:p>
-          <a:p>
-            <a:pPr>
-              <a:spcAft>
-                <a:spcPts val="700"/>
-              </a:spcAft>
-              <a:defRPr sz="1300">
-                <a:solidFill>
-                  <a:srgbClr val="F5F5F8"/>
-                </a:solidFill>
-              </a:defRPr>
-            </a:pPr>
-            <a:r>
-              <a:t>•  Step 2: Open file 'kernel.asm' from the project folder.</a:t>
-            </a:r>
-          </a:p>
-          <a:p>
-            <a:pPr>
-              <a:spcAft>
-                <a:spcPts val="700"/>
-              </a:spcAft>
-              <a:defRPr sz="1300">
-                <a:solidFill>
-                  <a:srgbClr val="F5F5F8"/>
-                </a:solidFill>
-              </a:defRPr>
-            </a:pPr>
-            <a:r>
-              <a:t>•  Step 3: Click the green 'Emulate' button on the toolbar.</a:t>
-            </a:r>
-          </a:p>
-          <a:p>
-            <a:pPr>
-              <a:spcAft>
-                <a:spcPts val="700"/>
-              </a:spcAft>
-              <a:defRPr sz="1300">
-                <a:solidFill>
-                  <a:srgbClr val="F5F5F8"/>
-                </a:solidFill>
-              </a:defRPr>
-            </a:pPr>
-            <a:r>
-              <a:t>•  Step 4: Click 'Run' in the emulator window.</a:t>
-            </a:r>
-          </a:p>
-          <a:p>
-            <a:pPr>
-              <a:spcAft>
-                <a:spcPts val="700"/>
-              </a:spcAft>
-              <a:defRPr sz="1300">
-                <a:solidFill>
-                  <a:srgbClr val="F5F5F8"/>
-                </a:solidFill>
-              </a:defRPr>
-            </a:pPr>
-            <a:r>
-              <a:t>•  Result: The Crimson Orbit Band starts instantly! You can play Piano (1), Guitar (2), Drums (3), or Songs (4) through the PC speaker.</a:t>
+              <a:t>•  Requested Feature: Allows users to compose, record, and play their own music.</a:t>
+            </a:r>
+          </a:p>
+          <a:p>
+            <a:pPr>
+              <a:spcAft>
+                <a:spcPts val="700"/>
+              </a:spcAft>
+              <a:defRPr sz="1300">
+                <a:solidFill>
+                  <a:srgbClr val="F5F5F8"/>
+                </a:solidFill>
+              </a:defRPr>
+            </a:pPr>
+            <a:r>
+              <a:t>•  Direct RAM Recording: Up to 60 notes stored dynamically in 8086 memory as [Frequency, Duration] pairs.</a:t>
+            </a:r>
+          </a:p>
+          <a:p>
+            <a:pPr>
+              <a:spcAft>
+                <a:spcPts val="700"/>
+              </a:spcAft>
+              <a:defRPr sz="1300">
+                <a:solidFill>
+                  <a:srgbClr val="F5F5F8"/>
+                </a:solidFill>
+              </a:defRPr>
+            </a:pPr>
+            <a:r>
+              <a:t>•  Live Track Tape: On-screen visual tape displays notes as you compose (e.g. [C5] [E5] [G5] [C6]...).</a:t>
+            </a:r>
+          </a:p>
+          <a:p>
+            <a:pPr>
+              <a:spcAft>
+                <a:spcPts val="700"/>
+              </a:spcAft>
+              <a:defRPr sz="1300">
+                <a:solidFill>
+                  <a:srgbClr val="F5F5F8"/>
+                </a:solidFill>
+              </a:defRPr>
+            </a:pPr>
+            <a:r>
+              <a:t>•  Full Editing Controls:</a:t>
+            </a:r>
+          </a:p>
+          <a:p>
+            <a:pPr>
+              <a:spcAft>
+                <a:spcPts val="700"/>
+              </a:spcAft>
+              <a:defRPr sz="1300">
+                <a:solidFill>
+                  <a:srgbClr val="F5F5F8"/>
+                </a:solidFill>
+              </a:defRPr>
+            </a:pPr>
+            <a:r>
+              <a:t>•  • [1..4] Note Lengths (Eighth, Quarter, Half, Whole)</a:t>
+            </a:r>
+          </a:p>
+          <a:p>
+            <a:pPr>
+              <a:spcAft>
+                <a:spcPts val="700"/>
+              </a:spcAft>
+              <a:defRPr sz="1300">
+                <a:solidFill>
+                  <a:srgbClr val="F5F5F8"/>
+                </a:solidFill>
+              </a:defRPr>
+            </a:pPr>
+            <a:r>
+              <a:t>•  • [B / Bksp] Undo last note, [C] Clear song, [L] Load starter melody</a:t>
+            </a:r>
+          </a:p>
+          <a:p>
+            <a:pPr>
+              <a:spcAft>
+                <a:spcPts val="700"/>
+              </a:spcAft>
+              <a:defRPr sz="1300">
+                <a:solidFill>
+                  <a:srgbClr val="F5F5F8"/>
+                </a:solidFill>
+              </a:defRPr>
+            </a:pPr>
+            <a:r>
+              <a:t>•  • [P] Live Playback: Plays user song with audible notes!</a:t>
+            </a:r>
+          </a:p>
+          <a:p>
+            <a:pPr>
+              <a:spcAft>
+                <a:spcPts val="700"/>
+              </a:spcAft>
+              <a:defRPr sz="1300">
+                <a:solidFill>
+                  <a:srgbClr val="F5F5F8"/>
+                </a:solidFill>
+              </a:defRPr>
+            </a:pPr>
+            <a:r>
+              <a:t>•  Jukebox Integration: Appears as Option 7 in Demo Songs Repertoire — playable on Piano, Guitar, or Drums!</a:t>
             </a:r>
           </a:p>
         </p:txBody>
@@ -5193,7 +5239,7 @@
               </a:defRPr>
             </a:pPr>
             <a:r>
-              <a:t>2. Running Real Sound Studio (Web)</a:t>
+              <a:t>In Web Studio (HTML/CSS/JS)</a:t>
             </a:r>
           </a:p>
         </p:txBody>
@@ -5228,7 +5274,7 @@
               </a:defRPr>
             </a:pPr>
             <a:r>
-              <a:t>Realistic Sound Demo</a:t>
+              <a:t>16-Step Multi-Track Studio Sequencer</a:t>
             </a:r>
           </a:p>
         </p:txBody>
@@ -5266,67 +5312,82 @@
               </a:defRPr>
             </a:pPr>
             <a:r>
-              <a:t>•  Step 1: Go to your Desktop or Downloads folder.</a:t>
-            </a:r>
-          </a:p>
-          <a:p>
-            <a:pPr>
-              <a:spcAft>
-                <a:spcPts val="700"/>
-              </a:spcAft>
-              <a:defRPr sz="1300">
-                <a:solidFill>
-                  <a:srgbClr val="F5F5F8"/>
-                </a:solidFill>
-              </a:defRPr>
-            </a:pPr>
-            <a:r>
-              <a:t>•  Step 2: Double-click 'CrimsonOrbit_RealStudio.html'.</a:t>
-            </a:r>
-          </a:p>
-          <a:p>
-            <a:pPr>
-              <a:spcAft>
-                <a:spcPts val="700"/>
-              </a:spcAft>
-              <a:defRPr sz="1300">
-                <a:solidFill>
-                  <a:srgbClr val="F5F5F8"/>
-                </a:solidFill>
-              </a:defRPr>
-            </a:pPr>
-            <a:r>
-              <a:t>•  Step 3: It opens instantly in Chrome or Edge without needing any server.</a:t>
-            </a:r>
-          </a:p>
-          <a:p>
-            <a:pPr>
-              <a:spcAft>
-                <a:spcPts val="700"/>
-              </a:spcAft>
-              <a:defRPr sz="1300">
-                <a:solidFill>
-                  <a:srgbClr val="F5F5F8"/>
-                </a:solidFill>
-              </a:defRPr>
-            </a:pPr>
-            <a:r>
-              <a:t>•  Step 4: Click 'Audio Engine Ready' or play keys Q to I.</a:t>
-            </a:r>
-          </a:p>
-          <a:p>
-            <a:pPr>
-              <a:spcAft>
-                <a:spcPts val="700"/>
-              </a:spcAft>
-              <a:defRPr sz="1300">
-                <a:solidFill>
-                  <a:srgbClr val="F5F5F8"/>
-                </a:solidFill>
-              </a:defRPr>
-            </a:pPr>
-            <a:r>
-              <a:t>•  Result: You will hear real Steinway grand piano, real Martin guitar, and real Ludwig drums with a moving visualizer!</a:t>
+              <a:t>•  16-Step Multi-Track Sequencer: Digital Audio Workstation (DAW) matrix.</a:t>
+            </a:r>
+          </a:p>
+          <a:p>
+            <a:pPr>
+              <a:spcAft>
+                <a:spcPts val="700"/>
+              </a:spcAft>
+              <a:defRPr sz="1300">
+                <a:solidFill>
+                  <a:srgbClr val="F5F5F8"/>
+                </a:solidFill>
+              </a:defRPr>
+            </a:pPr>
+            <a:r>
+              <a:t>•  8 Interactive Tracks: Piano (C5, G4, E4, C4), Guitar Chord, Drum Crash, Snare, and Kick.</a:t>
+            </a:r>
+          </a:p>
+          <a:p>
+            <a:pPr>
+              <a:spcAft>
+                <a:spcPts val="700"/>
+              </a:spcAft>
+              <a:defRPr sz="1300">
+                <a:solidFill>
+                  <a:srgbClr val="F5F5F8"/>
+                </a:solidFill>
+              </a:defRPr>
+            </a:pPr>
+            <a:r>
+              <a:t>•  Live Moving Sweep Cursor: Glowing sweep bar scans across all 16 steps in real time with the beat.</a:t>
+            </a:r>
+          </a:p>
+          <a:p>
+            <a:pPr>
+              <a:spcAft>
+                <a:spcPts val="700"/>
+              </a:spcAft>
+              <a:defRPr sz="1300">
+                <a:solidFill>
+                  <a:srgbClr val="F5F5F8"/>
+                </a:solidFill>
+              </a:defRPr>
+            </a:pPr>
+            <a:r>
+              <a:t>•  Tempo &amp; Controls: Real-time BPM slider (60 to 180 BPM), Load Starter Beat, and Clear Grid.</a:t>
+            </a:r>
+          </a:p>
+          <a:p>
+            <a:pPr>
+              <a:spcAft>
+                <a:spcPts val="700"/>
+              </a:spcAft>
+              <a:defRPr sz="1300">
+                <a:solidFill>
+                  <a:srgbClr val="F5F5F8"/>
+                </a:solidFill>
+              </a:defRPr>
+            </a:pPr>
+            <a:r>
+              <a:t>•  Live Tape &amp; Storage: Saves custom compositions to browser memory and logs notes to the tape.</a:t>
+            </a:r>
+          </a:p>
+          <a:p>
+            <a:pPr>
+              <a:spcAft>
+                <a:spcPts val="700"/>
+              </a:spcAft>
+              <a:defRPr sz="1300">
+                <a:solidFill>
+                  <a:srgbClr val="F5F5F8"/>
+                </a:solidFill>
+              </a:defRPr>
+            </a:pPr>
+            <a:r>
+              <a:t>•  Runs seamlessly offline in any browser with authentic studio audio samples.</a:t>
             </a:r>
           </a:p>
         </p:txBody>
@@ -5340,6 +5401,606 @@
 </file>
 
 <file path=ppt/slides/slide13.xml><?xml version="1.0" encoding="utf-8"?>
+<p:sld xmlns:a="http://schemas.openxmlformats.org/drawingml/2006/main" xmlns:p="http://schemas.openxmlformats.org/presentationml/2006/main" xmlns:r="http://schemas.openxmlformats.org/officeDocument/2006/relationships">
+  <p:cSld>
+    <p:spTree>
+      <p:nvGrpSpPr>
+        <p:cNvPr id="1" name=""/>
+        <p:cNvGrpSpPr/>
+        <p:nvPr/>
+      </p:nvGrpSpPr>
+      <p:grpSpPr/>
+      <p:sp>
+        <p:nvSpPr>
+          <p:cNvPr id="2" name="Rectangle 1"/>
+          <p:cNvSpPr/>
+          <p:nvPr/>
+        </p:nvSpPr>
+        <p:spPr>
+          <a:xfrm>
+            <a:off x="0" y="0"/>
+            <a:ext cx="12191695" cy="6858000"/>
+          </a:xfrm>
+          <a:prstGeom prst="rect">
+            <a:avLst/>
+          </a:prstGeom>
+          <a:solidFill>
+            <a:srgbClr val="0F1219"/>
+          </a:solidFill>
+          <a:ln>
+            <a:noFill/>
+          </a:ln>
+        </p:spPr>
+        <p:style>
+          <a:lnRef idx="1">
+            <a:schemeClr val="accent1"/>
+          </a:lnRef>
+          <a:fillRef idx="3">
+            <a:schemeClr val="accent1"/>
+          </a:fillRef>
+          <a:effectRef idx="2">
+            <a:schemeClr val="accent1"/>
+          </a:effectRef>
+          <a:fontRef idx="minor">
+            <a:schemeClr val="lt1"/>
+          </a:fontRef>
+        </p:style>
+        <p:txBody>
+          <a:bodyPr rtlCol="0" anchor="ctr"/>
+          <a:lstStyle/>
+          <a:p>
+            <a:pPr algn="ctr"/>
+          </a:p>
+        </p:txBody>
+      </p:sp>
+      <p:sp>
+        <p:nvSpPr>
+          <p:cNvPr id="3" name="TextBox 2"/>
+          <p:cNvSpPr txBox="1"/>
+          <p:nvPr/>
+        </p:nvSpPr>
+        <p:spPr>
+          <a:xfrm>
+            <a:off x="731520" y="365760"/>
+            <a:ext cx="10515600" cy="320040"/>
+          </a:xfrm>
+          <a:prstGeom prst="rect">
+            <a:avLst/>
+          </a:prstGeom>
+          <a:noFill/>
+        </p:spPr>
+        <p:txBody>
+          <a:bodyPr wrap="none">
+            <a:spAutoFit/>
+          </a:bodyPr>
+          <a:lstStyle/>
+          <a:p>
+            <a:pPr>
+              <a:defRPr sz="1100" b="1">
+                <a:solidFill>
+                  <a:srgbClr val="FFB914"/>
+                </a:solidFill>
+              </a:defRPr>
+            </a:pPr>
+            <a:r>
+              <a:t>MICROPROCESSOR PROJECT • GROUP - 9</a:t>
+            </a:r>
+          </a:p>
+        </p:txBody>
+      </p:sp>
+      <p:sp>
+        <p:nvSpPr>
+          <p:cNvPr id="4" name="TextBox 3"/>
+          <p:cNvSpPr txBox="1"/>
+          <p:nvPr/>
+        </p:nvSpPr>
+        <p:spPr>
+          <a:xfrm>
+            <a:off x="731520" y="640080"/>
+            <a:ext cx="10515600" cy="594360"/>
+          </a:xfrm>
+          <a:prstGeom prst="rect">
+            <a:avLst/>
+          </a:prstGeom>
+          <a:noFill/>
+        </p:spPr>
+        <p:txBody>
+          <a:bodyPr wrap="none">
+            <a:spAutoFit/>
+          </a:bodyPr>
+          <a:lstStyle/>
+          <a:p>
+            <a:pPr>
+              <a:defRPr sz="2500" b="1">
+                <a:solidFill>
+                  <a:srgbClr val="F5F5F8"/>
+                </a:solidFill>
+              </a:defRPr>
+            </a:pPr>
+            <a:r>
+              <a:t>How to Run Our Project &amp; Live Demo</a:t>
+            </a:r>
+          </a:p>
+        </p:txBody>
+      </p:sp>
+      <p:sp>
+        <p:nvSpPr>
+          <p:cNvPr id="5" name="Rectangle 4"/>
+          <p:cNvSpPr/>
+          <p:nvPr/>
+        </p:nvSpPr>
+        <p:spPr>
+          <a:xfrm>
+            <a:off x="731520" y="1280160"/>
+            <a:ext cx="10728655" cy="27432"/>
+          </a:xfrm>
+          <a:prstGeom prst="rect">
+            <a:avLst/>
+          </a:prstGeom>
+          <a:solidFill>
+            <a:srgbClr val="EB3C3C"/>
+          </a:solidFill>
+          <a:ln>
+            <a:noFill/>
+          </a:ln>
+        </p:spPr>
+        <p:style>
+          <a:lnRef idx="1">
+            <a:schemeClr val="accent1"/>
+          </a:lnRef>
+          <a:fillRef idx="3">
+            <a:schemeClr val="accent1"/>
+          </a:fillRef>
+          <a:effectRef idx="2">
+            <a:schemeClr val="accent1"/>
+          </a:effectRef>
+          <a:fontRef idx="minor">
+            <a:schemeClr val="lt1"/>
+          </a:fontRef>
+        </p:style>
+        <p:txBody>
+          <a:bodyPr rtlCol="0" anchor="ctr"/>
+          <a:lstStyle/>
+          <a:p>
+            <a:pPr algn="ctr"/>
+          </a:p>
+        </p:txBody>
+      </p:sp>
+      <p:sp>
+        <p:nvSpPr>
+          <p:cNvPr id="6" name="Rounded Rectangle 5"/>
+          <p:cNvSpPr/>
+          <p:nvPr/>
+        </p:nvSpPr>
+        <p:spPr>
+          <a:xfrm>
+            <a:off x="731520" y="1463040"/>
+            <a:ext cx="5120640" cy="4846320"/>
+          </a:xfrm>
+          <a:prstGeom prst="roundRect">
+            <a:avLst/>
+          </a:prstGeom>
+          <a:solidFill>
+            <a:srgbClr val="191E2A"/>
+          </a:solidFill>
+          <a:ln w="19050">
+            <a:solidFill>
+              <a:srgbClr val="461E2A"/>
+            </a:solidFill>
+          </a:ln>
+        </p:spPr>
+        <p:style>
+          <a:lnRef idx="1">
+            <a:schemeClr val="accent1"/>
+          </a:lnRef>
+          <a:fillRef idx="3">
+            <a:schemeClr val="accent1"/>
+          </a:fillRef>
+          <a:effectRef idx="2">
+            <a:schemeClr val="accent1"/>
+          </a:effectRef>
+          <a:fontRef idx="minor">
+            <a:schemeClr val="lt1"/>
+          </a:fontRef>
+        </p:style>
+        <p:txBody>
+          <a:bodyPr rtlCol="0" anchor="ctr"/>
+          <a:lstStyle/>
+          <a:p>
+            <a:pPr algn="ctr"/>
+          </a:p>
+        </p:txBody>
+      </p:sp>
+      <p:sp>
+        <p:nvSpPr>
+          <p:cNvPr id="7" name="TextBox 6"/>
+          <p:cNvSpPr txBox="1"/>
+          <p:nvPr/>
+        </p:nvSpPr>
+        <p:spPr>
+          <a:xfrm>
+            <a:off x="960120" y="1627632"/>
+            <a:ext cx="4663440" cy="365760"/>
+          </a:xfrm>
+          <a:prstGeom prst="rect">
+            <a:avLst/>
+          </a:prstGeom>
+          <a:noFill/>
+        </p:spPr>
+        <p:txBody>
+          <a:bodyPr wrap="none">
+            <a:spAutoFit/>
+          </a:bodyPr>
+          <a:lstStyle/>
+          <a:p>
+            <a:pPr>
+              <a:defRPr sz="1700" b="1">
+                <a:solidFill>
+                  <a:srgbClr val="EB3C3C"/>
+                </a:solidFill>
+              </a:defRPr>
+            </a:pPr>
+            <a:r>
+              <a:t>1. Running in emu8086 (Assembly)</a:t>
+            </a:r>
+          </a:p>
+        </p:txBody>
+      </p:sp>
+      <p:sp>
+        <p:nvSpPr>
+          <p:cNvPr id="8" name="TextBox 7"/>
+          <p:cNvSpPr txBox="1"/>
+          <p:nvPr/>
+        </p:nvSpPr>
+        <p:spPr>
+          <a:xfrm>
+            <a:off x="960120" y="1965960"/>
+            <a:ext cx="4663440" cy="274320"/>
+          </a:xfrm>
+          <a:prstGeom prst="rect">
+            <a:avLst/>
+          </a:prstGeom>
+          <a:noFill/>
+        </p:spPr>
+        <p:txBody>
+          <a:bodyPr wrap="none">
+            <a:spAutoFit/>
+          </a:bodyPr>
+          <a:lstStyle/>
+          <a:p>
+            <a:pPr>
+              <a:defRPr sz="1100">
+                <a:solidFill>
+                  <a:srgbClr val="AAAFBE"/>
+                </a:solidFill>
+              </a:defRPr>
+            </a:pPr>
+            <a:r>
+              <a:t>Assembly Emulation Demo</a:t>
+            </a:r>
+          </a:p>
+        </p:txBody>
+      </p:sp>
+      <p:sp>
+        <p:nvSpPr>
+          <p:cNvPr id="9" name="TextBox 8"/>
+          <p:cNvSpPr txBox="1"/>
+          <p:nvPr/>
+        </p:nvSpPr>
+        <p:spPr>
+          <a:xfrm>
+            <a:off x="960120" y="2240280"/>
+            <a:ext cx="4663440" cy="3931920"/>
+          </a:xfrm>
+          <a:prstGeom prst="rect">
+            <a:avLst/>
+          </a:prstGeom>
+          <a:noFill/>
+        </p:spPr>
+        <p:txBody>
+          <a:bodyPr wrap="square">
+            <a:spAutoFit/>
+          </a:bodyPr>
+          <a:lstStyle/>
+          <a:p>
+            <a:pPr>
+              <a:spcAft>
+                <a:spcPts val="700"/>
+              </a:spcAft>
+              <a:defRPr sz="1300">
+                <a:solidFill>
+                  <a:srgbClr val="F5F5F8"/>
+                </a:solidFill>
+              </a:defRPr>
+            </a:pPr>
+            <a:r>
+              <a:t>•  Step 1: Open emu8086 software on the computer.</a:t>
+            </a:r>
+          </a:p>
+          <a:p>
+            <a:pPr>
+              <a:spcAft>
+                <a:spcPts val="700"/>
+              </a:spcAft>
+              <a:defRPr sz="1300">
+                <a:solidFill>
+                  <a:srgbClr val="F5F5F8"/>
+                </a:solidFill>
+              </a:defRPr>
+            </a:pPr>
+            <a:r>
+              <a:t>•  Step 2: Open file 'kernel.asm' from the project folder.</a:t>
+            </a:r>
+          </a:p>
+          <a:p>
+            <a:pPr>
+              <a:spcAft>
+                <a:spcPts val="700"/>
+              </a:spcAft>
+              <a:defRPr sz="1300">
+                <a:solidFill>
+                  <a:srgbClr val="F5F5F8"/>
+                </a:solidFill>
+              </a:defRPr>
+            </a:pPr>
+            <a:r>
+              <a:t>•  Step 3: Click the green 'Emulate' button on the toolbar.</a:t>
+            </a:r>
+          </a:p>
+          <a:p>
+            <a:pPr>
+              <a:spcAft>
+                <a:spcPts val="700"/>
+              </a:spcAft>
+              <a:defRPr sz="1300">
+                <a:solidFill>
+                  <a:srgbClr val="F5F5F8"/>
+                </a:solidFill>
+              </a:defRPr>
+            </a:pPr>
+            <a:r>
+              <a:t>•  Step 4: Click 'Run' in the emulator window.</a:t>
+            </a:r>
+          </a:p>
+          <a:p>
+            <a:pPr>
+              <a:spcAft>
+                <a:spcPts val="700"/>
+              </a:spcAft>
+              <a:defRPr sz="1300">
+                <a:solidFill>
+                  <a:srgbClr val="F5F5F8"/>
+                </a:solidFill>
+              </a:defRPr>
+            </a:pPr>
+            <a:r>
+              <a:t>•  Result: The Crimson Orbit Band starts instantly! You can play Piano (1), Guitar (2), Drums (3), or Songs (4) through the PC speaker.</a:t>
+            </a:r>
+          </a:p>
+        </p:txBody>
+      </p:sp>
+      <p:sp>
+        <p:nvSpPr>
+          <p:cNvPr id="10" name="Rounded Rectangle 9"/>
+          <p:cNvSpPr/>
+          <p:nvPr/>
+        </p:nvSpPr>
+        <p:spPr>
+          <a:xfrm>
+            <a:off x="6309360" y="1463040"/>
+            <a:ext cx="5120640" cy="4846320"/>
+          </a:xfrm>
+          <a:prstGeom prst="roundRect">
+            <a:avLst/>
+          </a:prstGeom>
+          <a:solidFill>
+            <a:srgbClr val="191E2A"/>
+          </a:solidFill>
+          <a:ln w="19050">
+            <a:solidFill>
+              <a:srgbClr val="461E2A"/>
+            </a:solidFill>
+          </a:ln>
+        </p:spPr>
+        <p:style>
+          <a:lnRef idx="1">
+            <a:schemeClr val="accent1"/>
+          </a:lnRef>
+          <a:fillRef idx="3">
+            <a:schemeClr val="accent1"/>
+          </a:fillRef>
+          <a:effectRef idx="2">
+            <a:schemeClr val="accent1"/>
+          </a:effectRef>
+          <a:fontRef idx="minor">
+            <a:schemeClr val="lt1"/>
+          </a:fontRef>
+        </p:style>
+        <p:txBody>
+          <a:bodyPr rtlCol="0" anchor="ctr"/>
+          <a:lstStyle/>
+          <a:p>
+            <a:pPr algn="ctr"/>
+          </a:p>
+        </p:txBody>
+      </p:sp>
+      <p:sp>
+        <p:nvSpPr>
+          <p:cNvPr id="11" name="TextBox 10"/>
+          <p:cNvSpPr txBox="1"/>
+          <p:nvPr/>
+        </p:nvSpPr>
+        <p:spPr>
+          <a:xfrm>
+            <a:off x="6537960" y="1627632"/>
+            <a:ext cx="4663440" cy="365760"/>
+          </a:xfrm>
+          <a:prstGeom prst="rect">
+            <a:avLst/>
+          </a:prstGeom>
+          <a:noFill/>
+        </p:spPr>
+        <p:txBody>
+          <a:bodyPr wrap="none">
+            <a:spAutoFit/>
+          </a:bodyPr>
+          <a:lstStyle/>
+          <a:p>
+            <a:pPr>
+              <a:defRPr sz="1700" b="1">
+                <a:solidFill>
+                  <a:srgbClr val="FFB914"/>
+                </a:solidFill>
+              </a:defRPr>
+            </a:pPr>
+            <a:r>
+              <a:t>2. Running Real Sound Studio (Web)</a:t>
+            </a:r>
+          </a:p>
+        </p:txBody>
+      </p:sp>
+      <p:sp>
+        <p:nvSpPr>
+          <p:cNvPr id="12" name="TextBox 11"/>
+          <p:cNvSpPr txBox="1"/>
+          <p:nvPr/>
+        </p:nvSpPr>
+        <p:spPr>
+          <a:xfrm>
+            <a:off x="6537960" y="1965960"/>
+            <a:ext cx="4663440" cy="274320"/>
+          </a:xfrm>
+          <a:prstGeom prst="rect">
+            <a:avLst/>
+          </a:prstGeom>
+          <a:noFill/>
+        </p:spPr>
+        <p:txBody>
+          <a:bodyPr wrap="none">
+            <a:spAutoFit/>
+          </a:bodyPr>
+          <a:lstStyle/>
+          <a:p>
+            <a:pPr>
+              <a:defRPr sz="1100">
+                <a:solidFill>
+                  <a:srgbClr val="AAAFBE"/>
+                </a:solidFill>
+              </a:defRPr>
+            </a:pPr>
+            <a:r>
+              <a:t>Realistic Sound Demo</a:t>
+            </a:r>
+          </a:p>
+        </p:txBody>
+      </p:sp>
+      <p:sp>
+        <p:nvSpPr>
+          <p:cNvPr id="13" name="TextBox 12"/>
+          <p:cNvSpPr txBox="1"/>
+          <p:nvPr/>
+        </p:nvSpPr>
+        <p:spPr>
+          <a:xfrm>
+            <a:off x="6537960" y="2240280"/>
+            <a:ext cx="4663440" cy="3931920"/>
+          </a:xfrm>
+          <a:prstGeom prst="rect">
+            <a:avLst/>
+          </a:prstGeom>
+          <a:noFill/>
+        </p:spPr>
+        <p:txBody>
+          <a:bodyPr wrap="square">
+            <a:spAutoFit/>
+          </a:bodyPr>
+          <a:lstStyle/>
+          <a:p>
+            <a:pPr>
+              <a:spcAft>
+                <a:spcPts val="700"/>
+              </a:spcAft>
+              <a:defRPr sz="1300">
+                <a:solidFill>
+                  <a:srgbClr val="F5F5F8"/>
+                </a:solidFill>
+              </a:defRPr>
+            </a:pPr>
+            <a:r>
+              <a:t>•  Step 1: Go to your Desktop or Downloads folder.</a:t>
+            </a:r>
+          </a:p>
+          <a:p>
+            <a:pPr>
+              <a:spcAft>
+                <a:spcPts val="700"/>
+              </a:spcAft>
+              <a:defRPr sz="1300">
+                <a:solidFill>
+                  <a:srgbClr val="F5F5F8"/>
+                </a:solidFill>
+              </a:defRPr>
+            </a:pPr>
+            <a:r>
+              <a:t>•  Step 2: Double-click 'CrimsonOrbit_RealStudio.html'.</a:t>
+            </a:r>
+          </a:p>
+          <a:p>
+            <a:pPr>
+              <a:spcAft>
+                <a:spcPts val="700"/>
+              </a:spcAft>
+              <a:defRPr sz="1300">
+                <a:solidFill>
+                  <a:srgbClr val="F5F5F8"/>
+                </a:solidFill>
+              </a:defRPr>
+            </a:pPr>
+            <a:r>
+              <a:t>•  Step 3: It opens instantly in Chrome or Edge without needing any server.</a:t>
+            </a:r>
+          </a:p>
+          <a:p>
+            <a:pPr>
+              <a:spcAft>
+                <a:spcPts val="700"/>
+              </a:spcAft>
+              <a:defRPr sz="1300">
+                <a:solidFill>
+                  <a:srgbClr val="F5F5F8"/>
+                </a:solidFill>
+              </a:defRPr>
+            </a:pPr>
+            <a:r>
+              <a:t>•  Step 4: Click 'Audio Engine Ready' or play keys Q to I.</a:t>
+            </a:r>
+          </a:p>
+          <a:p>
+            <a:pPr>
+              <a:spcAft>
+                <a:spcPts val="700"/>
+              </a:spcAft>
+              <a:defRPr sz="1300">
+                <a:solidFill>
+                  <a:srgbClr val="F5F5F8"/>
+                </a:solidFill>
+              </a:defRPr>
+            </a:pPr>
+            <a:r>
+              <a:t>•  Result: You will hear real Steinway grand piano, real Martin guitar, and real Ludwig drums with a moving visualizer!</a:t>
+            </a:r>
+          </a:p>
+        </p:txBody>
+      </p:sp>
+    </p:spTree>
+  </p:cSld>
+  <p:clrMapOvr>
+    <a:masterClrMapping/>
+  </p:clrMapOvr>
+</p:sld>
+</file>
+
+<file path=ppt/slides/slide14.xml><?xml version="1.0" encoding="utf-8"?>
 <p:sld xmlns:a="http://schemas.openxmlformats.org/drawingml/2006/main" xmlns:p="http://schemas.openxmlformats.org/presentationml/2006/main" xmlns:r="http://schemas.openxmlformats.org/officeDocument/2006/relationships">
   <p:cSld>
     <p:spTree>

</xml_diff>